<commit_message>
Add kexec: run a command or a shell inside a running job
Like srun --jobid=ID --pty bash on Slurm: `kexec NAME nvidia-smi` runs a
command in the job container and returns its exit code; `kexec NAME`
opens an interactive login shell (needs a terminal). Uses pods/exec,
which the Kubeflow default-editor service account already has.

Co-Authored-By: Claude Opus 5.5 <noreply@anthropic.com>
</commit_message>
<xml_diff>
--- a/docs/kjob-tutorial.pptx
+++ b/docs/kjob-tutorial.pptx
@@ -7330,7 +7330,7 @@
                 <a:latin typeface="Consolas"/>
                 <a:ea typeface="Microsoft JhengHei"/>
               </a:rPr>
-              <a:t>kclean</a:t>
+              <a:t>kexec NAME</a:t>
             </a:r>
           </a:p>
         </p:txBody>
@@ -7366,7 +7366,7 @@
                 <a:latin typeface="Calibri"/>
                 <a:ea typeface="Microsoft JhengHei"/>
               </a:rPr>
-              <a:t>清掉已結束的</a:t>
+              <a:t>進到工作裡</a:t>
             </a:r>
           </a:p>
         </p:txBody>
@@ -9407,8 +9407,8 @@
           <p:nvPr/>
         </p:nvGraphicFramePr>
         <p:xfrm>
-          <a:off x="548640" y="1600200"/>
-          <a:ext cx="11064240" cy="4297680"/>
+          <a:off x="548640" y="1554480"/>
+          <a:ext cx="11064240" cy="4425696"/>
         </p:xfrm>
         <a:graphic>
           <a:graphicData uri="http://schemas.openxmlformats.org/drawingml/2006/table">
@@ -9421,7 +9421,7 @@
                 <a:gridCol w="2743200"/>
                 <a:gridCol w="5394960"/>
               </a:tblGrid>
-              <a:tr h="429768">
+              <a:tr h="402336">
                 <a:tc>
                   <a:txBody>
                     <a:bodyPr wrap="square"/>
@@ -9492,7 +9492,7 @@
                   </a:tcPr>
                 </a:tc>
               </a:tr>
-              <a:tr h="429768">
+              <a:tr h="402336">
                 <a:tc>
                   <a:txBody>
                     <a:bodyPr wrap="square"/>
@@ -9563,7 +9563,7 @@
                   </a:tcPr>
                 </a:tc>
               </a:tr>
-              <a:tr h="429768">
+              <a:tr h="402336">
                 <a:tc>
                   <a:txBody>
                     <a:bodyPr wrap="square"/>
@@ -9634,7 +9634,7 @@
                   </a:tcPr>
                 </a:tc>
               </a:tr>
-              <a:tr h="429768">
+              <a:tr h="402336">
                 <a:tc>
                   <a:txBody>
                     <a:bodyPr wrap="square"/>
@@ -9705,7 +9705,7 @@
                   </a:tcPr>
                 </a:tc>
               </a:tr>
-              <a:tr h="429768">
+              <a:tr h="402336">
                 <a:tc>
                   <a:txBody>
                     <a:bodyPr wrap="square"/>
@@ -9776,7 +9776,7 @@
                   </a:tcPr>
                 </a:tc>
               </a:tr>
-              <a:tr h="429768">
+              <a:tr h="402336">
                 <a:tc>
                   <a:txBody>
                     <a:bodyPr wrap="square"/>
@@ -9847,7 +9847,7 @@
                   </a:tcPr>
                 </a:tc>
               </a:tr>
-              <a:tr h="429768">
+              <a:tr h="402336">
                 <a:tc>
                   <a:txBody>
                     <a:bodyPr wrap="square"/>
@@ -9918,7 +9918,7 @@
                   </a:tcPr>
                 </a:tc>
               </a:tr>
-              <a:tr h="429768">
+              <a:tr h="402336">
                 <a:tc>
                   <a:txBody>
                     <a:bodyPr wrap="square"/>
@@ -9989,7 +9989,7 @@
                   </a:tcPr>
                 </a:tc>
               </a:tr>
-              <a:tr h="429768">
+              <a:tr h="402336">
                 <a:tc>
                   <a:txBody>
                     <a:bodyPr wrap="square"/>
@@ -10003,7 +10003,7 @@
                           <a:latin typeface="Consolas"/>
                           <a:ea typeface="Microsoft JhengHei"/>
                         </a:rPr>
-                        <a:t>scancel</a:t>
+                        <a:t>srun --jobid --pty</a:t>
                       </a:r>
                     </a:p>
                   </a:txBody>
@@ -10026,7 +10026,7 @@
                           <a:latin typeface="Consolas"/>
                           <a:ea typeface="Microsoft JhengHei"/>
                         </a:rPr>
-                        <a:t>kcancel NAME</a:t>
+                        <a:t>kexec NAME [指令]</a:t>
                       </a:r>
                     </a:p>
                   </a:txBody>
@@ -10049,7 +10049,7 @@
                           <a:latin typeface="Calibri"/>
                           <a:ea typeface="Microsoft JhengHei"/>
                         </a:rPr>
-                        <a:t>取消工作</a:t>
+                        <a:t>進到執行中的工作：跑指令或開 shell</a:t>
                       </a:r>
                     </a:p>
                   </a:txBody>
@@ -10060,7 +10060,7 @@
                   </a:tcPr>
                 </a:tc>
               </a:tr>
-              <a:tr h="429768">
+              <a:tr h="402336">
                 <a:tc>
                   <a:txBody>
                     <a:bodyPr wrap="square"/>
@@ -10074,7 +10074,7 @@
                           <a:latin typeface="Consolas"/>
                           <a:ea typeface="Microsoft JhengHei"/>
                         </a:rPr>
-                        <a:t>#SBATCH</a:t>
+                        <a:t>scancel</a:t>
                       </a:r>
                     </a:p>
                   </a:txBody>
@@ -10097,7 +10097,7 @@
                           <a:latin typeface="Consolas"/>
                           <a:ea typeface="Microsoft JhengHei"/>
                         </a:rPr>
-                        <a:t>#SBATCH / #KJOB</a:t>
+                        <a:t>kcancel NAME</a:t>
                       </a:r>
                     </a:p>
                   </a:txBody>
@@ -10120,13 +10120,84 @@
                           <a:latin typeface="Calibri"/>
                           <a:ea typeface="Microsoft JhengHei"/>
                         </a:rPr>
+                        <a:t>取消工作</a:t>
+                      </a:r>
+                    </a:p>
+                  </a:txBody>
+                  <a:tcPr marL="91440" marR="91440" marT="36576" marB="36576" anchor="ctr">
+                    <a:solidFill>
+                      <a:srgbClr val="FFFFFF"/>
+                    </a:solidFill>
+                  </a:tcPr>
+                </a:tc>
+              </a:tr>
+              <a:tr h="402336">
+                <a:tc>
+                  <a:txBody>
+                    <a:bodyPr wrap="square"/>
+                    <a:lstStyle/>
+                    <a:p>
+                      <a:r>
+                        <a:rPr sz="1500" b="1" i="0">
+                          <a:solidFill>
+                            <a:srgbClr val="0B6B45"/>
+                          </a:solidFill>
+                          <a:latin typeface="Consolas"/>
+                          <a:ea typeface="Microsoft JhengHei"/>
+                        </a:rPr>
+                        <a:t>#SBATCH</a:t>
+                      </a:r>
+                    </a:p>
+                  </a:txBody>
+                  <a:tcPr marL="91440" marR="91440" marT="36576" marB="36576" anchor="ctr">
+                    <a:solidFill>
+                      <a:srgbClr val="F3F6F8"/>
+                    </a:solidFill>
+                  </a:tcPr>
+                </a:tc>
+                <a:tc>
+                  <a:txBody>
+                    <a:bodyPr wrap="square"/>
+                    <a:lstStyle/>
+                    <a:p>
+                      <a:r>
+                        <a:rPr sz="1500" b="1" i="0">
+                          <a:solidFill>
+                            <a:srgbClr val="0B6B45"/>
+                          </a:solidFill>
+                          <a:latin typeface="Consolas"/>
+                          <a:ea typeface="Microsoft JhengHei"/>
+                        </a:rPr>
+                        <a:t>#SBATCH / #KJOB</a:t>
+                      </a:r>
+                    </a:p>
+                  </a:txBody>
+                  <a:tcPr marL="91440" marR="91440" marT="36576" marB="36576" anchor="ctr">
+                    <a:solidFill>
+                      <a:srgbClr val="F3F6F8"/>
+                    </a:solidFill>
+                  </a:tcPr>
+                </a:tc>
+                <a:tc>
+                  <a:txBody>
+                    <a:bodyPr wrap="square"/>
+                    <a:lstStyle/>
+                    <a:p>
+                      <a:r>
+                        <a:rPr sz="1500" b="0" i="0">
+                          <a:solidFill>
+                            <a:srgbClr val="1B2733"/>
+                          </a:solidFill>
+                          <a:latin typeface="Calibri"/>
+                          <a:ea typeface="Microsoft JhengHei"/>
+                        </a:rPr>
                         <a:t>腳本開頭寫資源設定</a:t>
                       </a:r>
                     </a:p>
                   </a:txBody>
                   <a:tcPr marL="91440" marR="91440" marT="36576" marB="36576" anchor="ctr">
                     <a:solidFill>
-                      <a:srgbClr val="FFFFFF"/>
+                      <a:srgbClr val="F3F6F8"/>
                     </a:solidFill>
                   </a:tcPr>
                 </a:tc>
@@ -13983,7 +14054,7 @@
                 <a:latin typeface="Consolas"/>
                 <a:ea typeface="Microsoft JhengHei"/>
               </a:rPr>
-              <a:t>kacct</a:t>
+              <a:t>kexec NAME</a:t>
             </a:r>
           </a:p>
         </p:txBody>
@@ -14019,7 +14090,7 @@
                 <a:latin typeface="Calibri"/>
                 <a:ea typeface="Microsoft JhengHei"/>
               </a:rPr>
-              <a:t>歷史紀錄：成功與否、跑了多久</a:t>
+              <a:t>在工作裡跑指令（如 nvidia-smi）或開 shell</a:t>
             </a:r>
           </a:p>
         </p:txBody>
@@ -14109,7 +14180,7 @@
                 <a:latin typeface="Consolas"/>
                 <a:ea typeface="Microsoft JhengHei"/>
               </a:rPr>
-              <a:t>kcancel NAME</a:t>
+              <a:t>kacct</a:t>
             </a:r>
           </a:p>
         </p:txBody>
@@ -14145,7 +14216,7 @@
                 <a:latin typeface="Calibri"/>
                 <a:ea typeface="Microsoft JhengHei"/>
               </a:rPr>
-              <a:t>取消工作（日誌會保留）</a:t>
+              <a:t>歷史紀錄：成功與否、跑了多久</a:t>
             </a:r>
           </a:p>
         </p:txBody>

</xml_diff>

<commit_message>
Install the AI skills automatically on the first kjob command
pip has no post-install step, so users had to run `kjob install-skills`
separately. Now any kjob command installs the skills into
~/.claude/skills and/or ~/.codex/skills when those tools are present,
and updates them after a kjob upgrade unless the user edited them
(checksum in .kjob-installed). KJOB_NO_SKILLS=1 turns it off; tests set
it so they never write to the real home directory.

Co-Authored-By: Claude Opus 5.5 <noreply@anthropic.com>
</commit_message>
<xml_diff>
--- a/docs/kjob-tutorial.pptx
+++ b/docs/kjob-tutorial.pptx
@@ -5386,7 +5386,7 @@
                 <a:latin typeface="Calibri"/>
                 <a:ea typeface="Microsoft JhengHei"/>
               </a:rPr>
-              <a:t>安裝 skill 後，用一句話描述需求</a:t>
+              <a:t>裝好 kjob 就自動裝好 skill，用一句話描述需求</a:t>
             </a:r>
           </a:p>
         </p:txBody>
@@ -5478,7 +5478,7 @@
                 <a:latin typeface="Consolas"/>
                 <a:ea typeface="Microsoft JhengHei"/>
               </a:rPr>
-              <a:t>kjob install-skills</a:t>
+              <a:t>kinfo</a:t>
             </a:r>
           </a:p>
           <a:p>
@@ -5486,12 +5486,12 @@
             <a:r>
               <a:rPr sz="1400" b="0" i="0">
                 <a:solidFill>
-                  <a:srgbClr val="DCE6EE"/>
+                  <a:srgbClr val="4FD69C"/>
                 </a:solidFill>
                 <a:latin typeface="Consolas"/>
                 <a:ea typeface="Microsoft JhengHei"/>
               </a:rPr>
-              <a:t>installed ~/.claude/skills/kjob-jobs/SKILL.md</a:t>
+              <a:t>kjob: installed AI skills in ~/.claude/skills</a:t>
             </a:r>
           </a:p>
         </p:txBody>

</xml_diff>

<commit_message>
Add the tutorial as PDF; fix left alignment of code in the slides
GitHub cannot preview .pptx, so the README links docs/kjob-tutorial.pdf
(converted with LibreOffice); the .pptx stays for editing. Slides now
mention the automatic skill install, and code blocks and command labels
are left-aligned (unwrapped text boxes were centred when rendered).

Co-Authored-By: Claude Opus 5.5 <noreply@anthropic.com>
</commit_message>
<xml_diff>
--- a/docs/kjob-tutorial.pptx
+++ b/docs/kjob-tutorial.pptx
@@ -3806,7 +3806,7 @@
           <a:noFill/>
         </p:spPr>
         <p:txBody>
-          <a:bodyPr wrap="none" anchor="t" lIns="45720" rIns="45720" tIns="27432" bIns="27432">
+          <a:bodyPr wrap="square" anchor="t" lIns="45720" rIns="45720" tIns="27432" bIns="27432">
             <a:spAutoFit/>
           </a:bodyPr>
           <a:lstStyle/>
@@ -4094,7 +4094,7 @@
           <a:noFill/>
         </p:spPr>
         <p:txBody>
-          <a:bodyPr wrap="none" anchor="t" lIns="45720" rIns="45720" tIns="27432" bIns="27432">
+          <a:bodyPr wrap="square" anchor="t" lIns="45720" rIns="45720" tIns="27432" bIns="27432">
             <a:spAutoFit/>
           </a:bodyPr>
           <a:lstStyle/>
@@ -4306,7 +4306,7 @@
           <a:noFill/>
         </p:spPr>
         <p:txBody>
-          <a:bodyPr wrap="none" anchor="t" lIns="45720" rIns="45720" tIns="27432" bIns="27432">
+          <a:bodyPr wrap="square" anchor="t" lIns="45720" rIns="45720" tIns="27432" bIns="27432">
             <a:spAutoFit/>
           </a:bodyPr>
           <a:lstStyle/>
@@ -5454,7 +5454,7 @@
           <a:noFill/>
         </p:spPr>
         <p:txBody>
-          <a:bodyPr wrap="none" anchor="t" lIns="45720" rIns="45720" tIns="27432" bIns="27432">
+          <a:bodyPr wrap="square" anchor="t" lIns="45720" rIns="45720" tIns="27432" bIns="27432">
             <a:spAutoFit/>
           </a:bodyPr>
           <a:lstStyle/>
@@ -6136,7 +6136,7 @@
           <a:noFill/>
         </p:spPr>
         <p:txBody>
-          <a:bodyPr wrap="none" anchor="t" lIns="45720" rIns="45720" tIns="27432" bIns="27432">
+          <a:bodyPr wrap="square" anchor="t" lIns="45720" rIns="45720" tIns="27432" bIns="27432">
             <a:spAutoFit/>
           </a:bodyPr>
           <a:lstStyle/>
@@ -6254,7 +6254,7 @@
           <a:noFill/>
         </p:spPr>
         <p:txBody>
-          <a:bodyPr wrap="none" anchor="t" lIns="45720" rIns="45720" tIns="27432" bIns="27432">
+          <a:bodyPr wrap="square" anchor="t" lIns="45720" rIns="45720" tIns="27432" bIns="27432">
             <a:spAutoFit/>
           </a:bodyPr>
           <a:lstStyle/>
@@ -6372,7 +6372,7 @@
           <a:noFill/>
         </p:spPr>
         <p:txBody>
-          <a:bodyPr wrap="none" anchor="t" lIns="45720" rIns="45720" tIns="27432" bIns="27432">
+          <a:bodyPr wrap="square" anchor="t" lIns="45720" rIns="45720" tIns="27432" bIns="27432">
             <a:spAutoFit/>
           </a:bodyPr>
           <a:lstStyle/>
@@ -6490,7 +6490,7 @@
           <a:noFill/>
         </p:spPr>
         <p:txBody>
-          <a:bodyPr wrap="none" anchor="t" lIns="45720" rIns="45720" tIns="27432" bIns="27432">
+          <a:bodyPr wrap="square" anchor="t" lIns="45720" rIns="45720" tIns="27432" bIns="27432">
             <a:spAutoFit/>
           </a:bodyPr>
           <a:lstStyle/>
@@ -6608,7 +6608,7 @@
           <a:noFill/>
         </p:spPr>
         <p:txBody>
-          <a:bodyPr wrap="none" anchor="t" lIns="45720" rIns="45720" tIns="27432" bIns="27432">
+          <a:bodyPr wrap="square" anchor="t" lIns="45720" rIns="45720" tIns="27432" bIns="27432">
             <a:spAutoFit/>
           </a:bodyPr>
           <a:lstStyle/>
@@ -6726,7 +6726,7 @@
           <a:noFill/>
         </p:spPr>
         <p:txBody>
-          <a:bodyPr wrap="none" anchor="t" lIns="45720" rIns="45720" tIns="27432" bIns="27432">
+          <a:bodyPr wrap="square" anchor="t" lIns="45720" rIns="45720" tIns="27432" bIns="27432">
             <a:spAutoFit/>
           </a:bodyPr>
           <a:lstStyle/>
@@ -6844,7 +6844,7 @@
           <a:noFill/>
         </p:spPr>
         <p:txBody>
-          <a:bodyPr wrap="none" anchor="t" lIns="45720" rIns="45720" tIns="27432" bIns="27432">
+          <a:bodyPr wrap="square" anchor="t" lIns="45720" rIns="45720" tIns="27432" bIns="27432">
             <a:spAutoFit/>
           </a:bodyPr>
           <a:lstStyle/>
@@ -6962,7 +6962,7 @@
           <a:noFill/>
         </p:spPr>
         <p:txBody>
-          <a:bodyPr wrap="none" anchor="t" lIns="45720" rIns="45720" tIns="27432" bIns="27432">
+          <a:bodyPr wrap="square" anchor="t" lIns="45720" rIns="45720" tIns="27432" bIns="27432">
             <a:spAutoFit/>
           </a:bodyPr>
           <a:lstStyle/>
@@ -7080,7 +7080,7 @@
           <a:noFill/>
         </p:spPr>
         <p:txBody>
-          <a:bodyPr wrap="none" anchor="t" lIns="45720" rIns="45720" tIns="27432" bIns="27432">
+          <a:bodyPr wrap="square" anchor="t" lIns="45720" rIns="45720" tIns="27432" bIns="27432">
             <a:spAutoFit/>
           </a:bodyPr>
           <a:lstStyle/>
@@ -7198,7 +7198,7 @@
           <a:noFill/>
         </p:spPr>
         <p:txBody>
-          <a:bodyPr wrap="none" anchor="t" lIns="45720" rIns="45720" tIns="27432" bIns="27432">
+          <a:bodyPr wrap="square" anchor="t" lIns="45720" rIns="45720" tIns="27432" bIns="27432">
             <a:spAutoFit/>
           </a:bodyPr>
           <a:lstStyle/>
@@ -7316,7 +7316,7 @@
           <a:noFill/>
         </p:spPr>
         <p:txBody>
-          <a:bodyPr wrap="none" anchor="t" lIns="45720" rIns="45720" tIns="27432" bIns="27432">
+          <a:bodyPr wrap="square" anchor="t" lIns="45720" rIns="45720" tIns="27432" bIns="27432">
             <a:spAutoFit/>
           </a:bodyPr>
           <a:lstStyle/>
@@ -7434,7 +7434,7 @@
           <a:noFill/>
         </p:spPr>
         <p:txBody>
-          <a:bodyPr wrap="none" anchor="t" lIns="45720" rIns="45720" tIns="27432" bIns="27432">
+          <a:bodyPr wrap="square" anchor="t" lIns="45720" rIns="45720" tIns="27432" bIns="27432">
             <a:spAutoFit/>
           </a:bodyPr>
           <a:lstStyle/>
@@ -7604,42 +7604,6 @@
           <a:noFill/>
         </p:spPr>
         <p:txBody>
-          <a:bodyPr wrap="none" anchor="t" lIns="45720" rIns="45720" tIns="27432" bIns="27432">
-            <a:spAutoFit/>
-          </a:bodyPr>
-          <a:lstStyle/>
-          <a:p>
-            <a:pPr algn="l"/>
-            <a:r>
-              <a:rPr sz="1800" b="1" i="0">
-                <a:solidFill>
-                  <a:srgbClr val="4FD69C"/>
-                </a:solidFill>
-                <a:latin typeface="Consolas"/>
-                <a:ea typeface="Microsoft JhengHei"/>
-              </a:rPr>
-              <a:t>README.md</a:t>
-            </a:r>
-          </a:p>
-        </p:txBody>
-      </p:sp>
-      <p:sp>
-        <p:nvSpPr>
-          <p:cNvPr id="4" name="doc-d-0"/>
-          <p:cNvSpPr txBox="1"/>
-          <p:nvPr/>
-        </p:nvSpPr>
-        <p:spPr>
-          <a:xfrm>
-            <a:off x="4846320" y="1920240"/>
-            <a:ext cx="6400800" cy="502920"/>
-          </a:xfrm>
-          <a:prstGeom prst="rect">
-            <a:avLst/>
-          </a:prstGeom>
-          <a:noFill/>
-        </p:spPr>
-        <p:txBody>
           <a:bodyPr wrap="square" anchor="t" lIns="45720" rIns="45720" tIns="27432" bIns="27432">
             <a:spAutoFit/>
           </a:bodyPr>
@@ -7647,63 +7611,27 @@
           <a:p>
             <a:pPr algn="l"/>
             <a:r>
-              <a:rPr sz="1800" b="0" i="0">
-                <a:solidFill>
-                  <a:srgbClr val="DCE6EE"/>
-                </a:solidFill>
-                <a:latin typeface="Calibri"/>
-                <a:ea typeface="Microsoft JhengHei"/>
-              </a:rPr>
-              <a:t>簡介、安裝、指令一覽</a:t>
-            </a:r>
-          </a:p>
-        </p:txBody>
-      </p:sp>
-      <p:sp>
-        <p:nvSpPr>
-          <p:cNvPr id="5" name="doc-f-1"/>
+              <a:rPr sz="1800" b="1" i="0">
+                <a:solidFill>
+                  <a:srgbClr val="4FD69C"/>
+                </a:solidFill>
+                <a:latin typeface="Consolas"/>
+                <a:ea typeface="Microsoft JhengHei"/>
+              </a:rPr>
+              <a:t>README.md</a:t>
+            </a:r>
+          </a:p>
+        </p:txBody>
+      </p:sp>
+      <p:sp>
+        <p:nvSpPr>
+          <p:cNvPr id="4" name="doc-d-0"/>
           <p:cNvSpPr txBox="1"/>
           <p:nvPr/>
         </p:nvSpPr>
         <p:spPr>
           <a:xfrm>
-            <a:off x="731520" y="2633472"/>
-            <a:ext cx="4023360" cy="502920"/>
-          </a:xfrm>
-          <a:prstGeom prst="rect">
-            <a:avLst/>
-          </a:prstGeom>
-          <a:noFill/>
-        </p:spPr>
-        <p:txBody>
-          <a:bodyPr wrap="none" anchor="t" lIns="45720" rIns="45720" tIns="27432" bIns="27432">
-            <a:spAutoFit/>
-          </a:bodyPr>
-          <a:lstStyle/>
-          <a:p>
-            <a:pPr algn="l"/>
-            <a:r>
-              <a:rPr sz="1800" b="1" i="0">
-                <a:solidFill>
-                  <a:srgbClr val="4FD69C"/>
-                </a:solidFill>
-                <a:latin typeface="Consolas"/>
-                <a:ea typeface="Microsoft JhengHei"/>
-              </a:rPr>
-              <a:t>TRIAL_GUIDE.md</a:t>
-            </a:r>
-          </a:p>
-        </p:txBody>
-      </p:sp>
-      <p:sp>
-        <p:nvSpPr>
-          <p:cNvPr id="6" name="doc-d-1"/>
-          <p:cNvSpPr txBox="1"/>
-          <p:nvPr/>
-        </p:nvSpPr>
-        <p:spPr>
-          <a:xfrm>
-            <a:off x="4846320" y="2633472"/>
+            <a:off x="4846320" y="1920240"/>
             <a:ext cx="6400800" cy="502920"/>
           </a:xfrm>
           <a:prstGeom prst="rect">
@@ -7726,57 +7654,21 @@
                 <a:latin typeface="Calibri"/>
                 <a:ea typeface="Microsoft JhengHei"/>
               </a:rPr>
-              <a:t>10 分鐘新手上手</a:t>
-            </a:r>
-          </a:p>
-        </p:txBody>
-      </p:sp>
-      <p:sp>
-        <p:nvSpPr>
-          <p:cNvPr id="7" name="doc-f-2"/>
+              <a:t>簡介、安裝、指令一覽</a:t>
+            </a:r>
+          </a:p>
+        </p:txBody>
+      </p:sp>
+      <p:sp>
+        <p:nvSpPr>
+          <p:cNvPr id="5" name="doc-f-1"/>
           <p:cNvSpPr txBox="1"/>
           <p:nvPr/>
         </p:nvSpPr>
         <p:spPr>
           <a:xfrm>
-            <a:off x="731520" y="3346704"/>
+            <a:off x="731520" y="2633472"/>
             <a:ext cx="4023360" cy="502920"/>
-          </a:xfrm>
-          <a:prstGeom prst="rect">
-            <a:avLst/>
-          </a:prstGeom>
-          <a:noFill/>
-        </p:spPr>
-        <p:txBody>
-          <a:bodyPr wrap="none" anchor="t" lIns="45720" rIns="45720" tIns="27432" bIns="27432">
-            <a:spAutoFit/>
-          </a:bodyPr>
-          <a:lstStyle/>
-          <a:p>
-            <a:pPr algn="l"/>
-            <a:r>
-              <a:rPr sz="1800" b="1" i="0">
-                <a:solidFill>
-                  <a:srgbClr val="4FD69C"/>
-                </a:solidFill>
-                <a:latin typeface="Consolas"/>
-                <a:ea typeface="Microsoft JhengHei"/>
-              </a:rPr>
-              <a:t>docs/USER_GUIDE.md</a:t>
-            </a:r>
-          </a:p>
-        </p:txBody>
-      </p:sp>
-      <p:sp>
-        <p:nvSpPr>
-          <p:cNvPr id="8" name="doc-d-2"/>
-          <p:cNvSpPr txBox="1"/>
-          <p:nvPr/>
-        </p:nvSpPr>
-        <p:spPr>
-          <a:xfrm>
-            <a:off x="4846320" y="3346704"/>
-            <a:ext cx="6400800" cy="502920"/>
           </a:xfrm>
           <a:prstGeom prst="rect">
             <a:avLst/>
@@ -7791,63 +7683,27 @@
           <a:p>
             <a:pPr algn="l"/>
             <a:r>
-              <a:rPr sz="1800" b="0" i="0">
-                <a:solidFill>
-                  <a:srgbClr val="DCE6EE"/>
-                </a:solidFill>
-                <a:latin typeface="Calibri"/>
-                <a:ea typeface="Microsoft JhengHei"/>
-              </a:rPr>
-              <a:t>所有指令與選項、排錯</a:t>
-            </a:r>
-          </a:p>
-        </p:txBody>
-      </p:sp>
-      <p:sp>
-        <p:nvSpPr>
-          <p:cNvPr id="9" name="doc-f-3"/>
+              <a:rPr sz="1800" b="1" i="0">
+                <a:solidFill>
+                  <a:srgbClr val="4FD69C"/>
+                </a:solidFill>
+                <a:latin typeface="Consolas"/>
+                <a:ea typeface="Microsoft JhengHei"/>
+              </a:rPr>
+              <a:t>TRIAL_GUIDE.md</a:t>
+            </a:r>
+          </a:p>
+        </p:txBody>
+      </p:sp>
+      <p:sp>
+        <p:nvSpPr>
+          <p:cNvPr id="6" name="doc-d-1"/>
           <p:cNvSpPr txBox="1"/>
           <p:nvPr/>
         </p:nvSpPr>
         <p:spPr>
           <a:xfrm>
-            <a:off x="731520" y="4059935"/>
-            <a:ext cx="4023360" cy="502920"/>
-          </a:xfrm>
-          <a:prstGeom prst="rect">
-            <a:avLst/>
-          </a:prstGeom>
-          <a:noFill/>
-        </p:spPr>
-        <p:txBody>
-          <a:bodyPr wrap="none" anchor="t" lIns="45720" rIns="45720" tIns="27432" bIns="27432">
-            <a:spAutoFit/>
-          </a:bodyPr>
-          <a:lstStyle/>
-          <a:p>
-            <a:pPr algn="l"/>
-            <a:r>
-              <a:rPr sz="1800" b="1" i="0">
-                <a:solidFill>
-                  <a:srgbClr val="4FD69C"/>
-                </a:solidFill>
-                <a:latin typeface="Consolas"/>
-                <a:ea typeface="Microsoft JhengHei"/>
-              </a:rPr>
-              <a:t>docs/ADMIN.md</a:t>
-            </a:r>
-          </a:p>
-        </p:txBody>
-      </p:sp>
-      <p:sp>
-        <p:nvSpPr>
-          <p:cNvPr id="10" name="doc-d-3"/>
-          <p:cNvSpPr txBox="1"/>
-          <p:nvPr/>
-        </p:nvSpPr>
-        <p:spPr>
-          <a:xfrm>
-            <a:off x="4846320" y="4059935"/>
+            <a:off x="4846320" y="2633472"/>
             <a:ext cx="6400800" cy="502920"/>
           </a:xfrm>
           <a:prstGeom prst="rect">
@@ -7870,6 +7726,150 @@
                 <a:latin typeface="Calibri"/>
                 <a:ea typeface="Microsoft JhengHei"/>
               </a:rPr>
+              <a:t>10 分鐘新手上手</a:t>
+            </a:r>
+          </a:p>
+        </p:txBody>
+      </p:sp>
+      <p:sp>
+        <p:nvSpPr>
+          <p:cNvPr id="7" name="doc-f-2"/>
+          <p:cNvSpPr txBox="1"/>
+          <p:nvPr/>
+        </p:nvSpPr>
+        <p:spPr>
+          <a:xfrm>
+            <a:off x="731520" y="3346704"/>
+            <a:ext cx="4023360" cy="502920"/>
+          </a:xfrm>
+          <a:prstGeom prst="rect">
+            <a:avLst/>
+          </a:prstGeom>
+          <a:noFill/>
+        </p:spPr>
+        <p:txBody>
+          <a:bodyPr wrap="square" anchor="t" lIns="45720" rIns="45720" tIns="27432" bIns="27432">
+            <a:spAutoFit/>
+          </a:bodyPr>
+          <a:lstStyle/>
+          <a:p>
+            <a:pPr algn="l"/>
+            <a:r>
+              <a:rPr sz="1800" b="1" i="0">
+                <a:solidFill>
+                  <a:srgbClr val="4FD69C"/>
+                </a:solidFill>
+                <a:latin typeface="Consolas"/>
+                <a:ea typeface="Microsoft JhengHei"/>
+              </a:rPr>
+              <a:t>docs/USER_GUIDE.md</a:t>
+            </a:r>
+          </a:p>
+        </p:txBody>
+      </p:sp>
+      <p:sp>
+        <p:nvSpPr>
+          <p:cNvPr id="8" name="doc-d-2"/>
+          <p:cNvSpPr txBox="1"/>
+          <p:nvPr/>
+        </p:nvSpPr>
+        <p:spPr>
+          <a:xfrm>
+            <a:off x="4846320" y="3346704"/>
+            <a:ext cx="6400800" cy="502920"/>
+          </a:xfrm>
+          <a:prstGeom prst="rect">
+            <a:avLst/>
+          </a:prstGeom>
+          <a:noFill/>
+        </p:spPr>
+        <p:txBody>
+          <a:bodyPr wrap="square" anchor="t" lIns="45720" rIns="45720" tIns="27432" bIns="27432">
+            <a:spAutoFit/>
+          </a:bodyPr>
+          <a:lstStyle/>
+          <a:p>
+            <a:pPr algn="l"/>
+            <a:r>
+              <a:rPr sz="1800" b="0" i="0">
+                <a:solidFill>
+                  <a:srgbClr val="DCE6EE"/>
+                </a:solidFill>
+                <a:latin typeface="Calibri"/>
+                <a:ea typeface="Microsoft JhengHei"/>
+              </a:rPr>
+              <a:t>所有指令與選項、排錯</a:t>
+            </a:r>
+          </a:p>
+        </p:txBody>
+      </p:sp>
+      <p:sp>
+        <p:nvSpPr>
+          <p:cNvPr id="9" name="doc-f-3"/>
+          <p:cNvSpPr txBox="1"/>
+          <p:nvPr/>
+        </p:nvSpPr>
+        <p:spPr>
+          <a:xfrm>
+            <a:off x="731520" y="4059935"/>
+            <a:ext cx="4023360" cy="502920"/>
+          </a:xfrm>
+          <a:prstGeom prst="rect">
+            <a:avLst/>
+          </a:prstGeom>
+          <a:noFill/>
+        </p:spPr>
+        <p:txBody>
+          <a:bodyPr wrap="square" anchor="t" lIns="45720" rIns="45720" tIns="27432" bIns="27432">
+            <a:spAutoFit/>
+          </a:bodyPr>
+          <a:lstStyle/>
+          <a:p>
+            <a:pPr algn="l"/>
+            <a:r>
+              <a:rPr sz="1800" b="1" i="0">
+                <a:solidFill>
+                  <a:srgbClr val="4FD69C"/>
+                </a:solidFill>
+                <a:latin typeface="Consolas"/>
+                <a:ea typeface="Microsoft JhengHei"/>
+              </a:rPr>
+              <a:t>docs/ADMIN.md</a:t>
+            </a:r>
+          </a:p>
+        </p:txBody>
+      </p:sp>
+      <p:sp>
+        <p:nvSpPr>
+          <p:cNvPr id="10" name="doc-d-3"/>
+          <p:cNvSpPr txBox="1"/>
+          <p:nvPr/>
+        </p:nvSpPr>
+        <p:spPr>
+          <a:xfrm>
+            <a:off x="4846320" y="4059935"/>
+            <a:ext cx="6400800" cy="502920"/>
+          </a:xfrm>
+          <a:prstGeom prst="rect">
+            <a:avLst/>
+          </a:prstGeom>
+          <a:noFill/>
+        </p:spPr>
+        <p:txBody>
+          <a:bodyPr wrap="square" anchor="t" lIns="45720" rIns="45720" tIns="27432" bIns="27432">
+            <a:spAutoFit/>
+          </a:bodyPr>
+          <a:lstStyle/>
+          <a:p>
+            <a:pPr algn="l"/>
+            <a:r>
+              <a:rPr sz="1800" b="0" i="0">
+                <a:solidFill>
+                  <a:srgbClr val="DCE6EE"/>
+                </a:solidFill>
+                <a:latin typeface="Calibri"/>
+                <a:ea typeface="Microsoft JhengHei"/>
+              </a:rPr>
               <a:t>管理員：權限、叢集狀態服務</a:t>
             </a:r>
           </a:p>
@@ -7892,7 +7892,7 @@
           <a:noFill/>
         </p:spPr>
         <p:txBody>
-          <a:bodyPr wrap="none" anchor="t" lIns="45720" rIns="45720" tIns="27432" bIns="27432">
+          <a:bodyPr wrap="square" anchor="t" lIns="45720" rIns="45720" tIns="27432" bIns="27432">
             <a:spAutoFit/>
           </a:bodyPr>
           <a:lstStyle/>
@@ -10403,7 +10403,7 @@
           <a:noFill/>
         </p:spPr>
         <p:txBody>
-          <a:bodyPr wrap="none" anchor="t" lIns="45720" rIns="45720" tIns="27432" bIns="27432">
+          <a:bodyPr wrap="square" anchor="t" lIns="45720" rIns="45720" tIns="27432" bIns="27432">
             <a:spAutoFit/>
           </a:bodyPr>
           <a:lstStyle/>
@@ -11097,7 +11097,7 @@
           <a:noFill/>
         </p:spPr>
         <p:txBody>
-          <a:bodyPr wrap="none" anchor="t" lIns="45720" rIns="45720" tIns="27432" bIns="27432">
+          <a:bodyPr wrap="square" anchor="t" lIns="45720" rIns="45720" tIns="27432" bIns="27432">
             <a:spAutoFit/>
           </a:bodyPr>
           <a:lstStyle/>
@@ -11323,7 +11323,7 @@
           <a:noFill/>
         </p:spPr>
         <p:txBody>
-          <a:bodyPr wrap="none" anchor="t" lIns="45720" rIns="45720" tIns="27432" bIns="27432">
+          <a:bodyPr wrap="square" anchor="t" lIns="45720" rIns="45720" tIns="27432" bIns="27432">
             <a:spAutoFit/>
           </a:bodyPr>
           <a:lstStyle/>
@@ -11445,7 +11445,7 @@
           <a:noFill/>
         </p:spPr>
         <p:txBody>
-          <a:bodyPr wrap="none" anchor="t" lIns="45720" rIns="45720" tIns="27432" bIns="27432">
+          <a:bodyPr wrap="square" anchor="t" lIns="45720" rIns="45720" tIns="27432" bIns="27432">
             <a:spAutoFit/>
           </a:bodyPr>
           <a:lstStyle/>
@@ -11567,7 +11567,7 @@
           <a:noFill/>
         </p:spPr>
         <p:txBody>
-          <a:bodyPr wrap="none" anchor="t" lIns="45720" rIns="45720" tIns="27432" bIns="27432">
+          <a:bodyPr wrap="square" anchor="t" lIns="45720" rIns="45720" tIns="27432" bIns="27432">
             <a:spAutoFit/>
           </a:bodyPr>
           <a:lstStyle/>
@@ -11823,7 +11823,7 @@
           <a:noFill/>
         </p:spPr>
         <p:txBody>
-          <a:bodyPr wrap="none" anchor="t" lIns="45720" rIns="45720" tIns="27432" bIns="27432">
+          <a:bodyPr wrap="square" anchor="t" lIns="45720" rIns="45720" tIns="27432" bIns="27432">
             <a:spAutoFit/>
           </a:bodyPr>
           <a:lstStyle/>
@@ -12019,7 +12019,7 @@
           <a:noFill/>
         </p:spPr>
         <p:txBody>
-          <a:bodyPr wrap="none" anchor="t" lIns="45720" rIns="45720" tIns="27432" bIns="27432">
+          <a:bodyPr wrap="square" anchor="t" lIns="45720" rIns="45720" tIns="27432" bIns="27432">
             <a:spAutoFit/>
           </a:bodyPr>
           <a:lstStyle/>
@@ -12137,7 +12137,7 @@
           <a:noFill/>
         </p:spPr>
         <p:txBody>
-          <a:bodyPr wrap="none" anchor="t" lIns="45720" rIns="45720" tIns="27432" bIns="27432">
+          <a:bodyPr wrap="square" anchor="t" lIns="45720" rIns="45720" tIns="27432" bIns="27432">
             <a:spAutoFit/>
           </a:bodyPr>
           <a:lstStyle/>
@@ -12255,7 +12255,7 @@
           <a:noFill/>
         </p:spPr>
         <p:txBody>
-          <a:bodyPr wrap="none" anchor="t" lIns="45720" rIns="45720" tIns="27432" bIns="27432">
+          <a:bodyPr wrap="square" anchor="t" lIns="45720" rIns="45720" tIns="27432" bIns="27432">
             <a:spAutoFit/>
           </a:bodyPr>
           <a:lstStyle/>
@@ -12373,7 +12373,7 @@
           <a:noFill/>
         </p:spPr>
         <p:txBody>
-          <a:bodyPr wrap="none" anchor="t" lIns="45720" rIns="45720" tIns="27432" bIns="27432">
+          <a:bodyPr wrap="square" anchor="t" lIns="45720" rIns="45720" tIns="27432" bIns="27432">
             <a:spAutoFit/>
           </a:bodyPr>
           <a:lstStyle/>
@@ -12625,7 +12625,7 @@
           <a:noFill/>
         </p:spPr>
         <p:txBody>
-          <a:bodyPr wrap="none" anchor="t" lIns="45720" rIns="45720" tIns="27432" bIns="27432">
+          <a:bodyPr wrap="square" anchor="t" lIns="45720" rIns="45720" tIns="27432" bIns="27432">
             <a:spAutoFit/>
           </a:bodyPr>
           <a:lstStyle/>
@@ -13536,7 +13536,7 @@
           <a:noFill/>
         </p:spPr>
         <p:txBody>
-          <a:bodyPr wrap="none" anchor="ctr" lIns="45720" rIns="45720" tIns="27432" bIns="27432">
+          <a:bodyPr wrap="square" anchor="ctr" lIns="45720" rIns="45720" tIns="27432" bIns="27432">
             <a:spAutoFit/>
           </a:bodyPr>
           <a:lstStyle/>
@@ -13662,7 +13662,7 @@
           <a:noFill/>
         </p:spPr>
         <p:txBody>
-          <a:bodyPr wrap="none" anchor="ctr" lIns="45720" rIns="45720" tIns="27432" bIns="27432">
+          <a:bodyPr wrap="square" anchor="ctr" lIns="45720" rIns="45720" tIns="27432" bIns="27432">
             <a:spAutoFit/>
           </a:bodyPr>
           <a:lstStyle/>
@@ -13788,7 +13788,7 @@
           <a:noFill/>
         </p:spPr>
         <p:txBody>
-          <a:bodyPr wrap="none" anchor="ctr" lIns="45720" rIns="45720" tIns="27432" bIns="27432">
+          <a:bodyPr wrap="square" anchor="ctr" lIns="45720" rIns="45720" tIns="27432" bIns="27432">
             <a:spAutoFit/>
           </a:bodyPr>
           <a:lstStyle/>
@@ -13914,7 +13914,7 @@
           <a:noFill/>
         </p:spPr>
         <p:txBody>
-          <a:bodyPr wrap="none" anchor="ctr" lIns="45720" rIns="45720" tIns="27432" bIns="27432">
+          <a:bodyPr wrap="square" anchor="ctr" lIns="45720" rIns="45720" tIns="27432" bIns="27432">
             <a:spAutoFit/>
           </a:bodyPr>
           <a:lstStyle/>
@@ -14040,7 +14040,7 @@
           <a:noFill/>
         </p:spPr>
         <p:txBody>
-          <a:bodyPr wrap="none" anchor="ctr" lIns="45720" rIns="45720" tIns="27432" bIns="27432">
+          <a:bodyPr wrap="square" anchor="ctr" lIns="45720" rIns="45720" tIns="27432" bIns="27432">
             <a:spAutoFit/>
           </a:bodyPr>
           <a:lstStyle/>
@@ -14166,7 +14166,7 @@
           <a:noFill/>
         </p:spPr>
         <p:txBody>
-          <a:bodyPr wrap="none" anchor="ctr" lIns="45720" rIns="45720" tIns="27432" bIns="27432">
+          <a:bodyPr wrap="square" anchor="ctr" lIns="45720" rIns="45720" tIns="27432" bIns="27432">
             <a:spAutoFit/>
           </a:bodyPr>
           <a:lstStyle/>
@@ -14284,7 +14284,7 @@
           <a:noFill/>
         </p:spPr>
         <p:txBody>
-          <a:bodyPr wrap="none" anchor="t" lIns="45720" rIns="45720" tIns="27432" bIns="27432">
+          <a:bodyPr wrap="square" anchor="t" lIns="45720" rIns="45720" tIns="27432" bIns="27432">
             <a:spAutoFit/>
           </a:bodyPr>
           <a:lstStyle/>
@@ -14624,7 +14624,7 @@
           <a:noFill/>
         </p:spPr>
         <p:txBody>
-          <a:bodyPr wrap="none" anchor="t" lIns="45720" rIns="45720" tIns="27432" bIns="27432">
+          <a:bodyPr wrap="square" anchor="t" lIns="45720" rIns="45720" tIns="27432" bIns="27432">
             <a:spAutoFit/>
           </a:bodyPr>
           <a:lstStyle/>
@@ -14817,7 +14817,7 @@
           <a:noFill/>
         </p:spPr>
         <p:txBody>
-          <a:bodyPr wrap="none" anchor="t" lIns="45720" rIns="45720" tIns="27432" bIns="27432">
+          <a:bodyPr wrap="square" anchor="t" lIns="45720" rIns="45720" tIns="27432" bIns="27432">
             <a:spAutoFit/>
           </a:bodyPr>
           <a:lstStyle/>
@@ -14939,7 +14939,7 @@
           <a:noFill/>
         </p:spPr>
         <p:txBody>
-          <a:bodyPr wrap="none" anchor="t" lIns="45720" rIns="45720" tIns="27432" bIns="27432">
+          <a:bodyPr wrap="square" anchor="t" lIns="45720" rIns="45720" tIns="27432" bIns="27432">
             <a:spAutoFit/>
           </a:bodyPr>
           <a:lstStyle/>

</xml_diff>

<commit_message>
Always install the AI skills into ~/.claude/skills and ~/.agents/skills
~/.agents/skills is the shared Agent Skills location read by Codex,
OpenCode, Gemini CLI, Cursor and others (Codex no longer documents
~/.codex/skills); ~/.claude/skills is for Claude Code and is also read
by OpenCode. Installing whether or not a tool is present means an
assistant installed later finds the skills too.

Co-Authored-By: Claude Opus 5.5 <noreply@anthropic.com>
</commit_message>
<xml_diff>
--- a/docs/kjob-tutorial.pptx
+++ b/docs/kjob-tutorial.pptx
@@ -5400,7 +5400,7 @@
         <p:spPr>
           <a:xfrm>
             <a:off x="548640" y="1600200"/>
-            <a:ext cx="5486400" cy="1051560"/>
+            <a:ext cx="5486400" cy="1188720"/>
           </a:xfrm>
           <a:prstGeom prst="roundRect">
             <a:avLst>
@@ -5446,7 +5446,7 @@
         <p:spPr>
           <a:xfrm>
             <a:off x="777240" y="1764792"/>
-            <a:ext cx="5029200" cy="777239"/>
+            <a:ext cx="5029200" cy="914400"/>
           </a:xfrm>
           <a:prstGeom prst="rect">
             <a:avLst/>
@@ -5461,7 +5461,7 @@
           <a:p>
             <a:pPr algn="l"/>
             <a:r>
-              <a:rPr sz="1400" b="1" i="0">
+              <a:rPr sz="1300" b="1" i="0">
                 <a:solidFill>
                   <a:srgbClr val="4FD69C"/>
                 </a:solidFill>
@@ -5471,7 +5471,7 @@
               <a:t>$ </a:t>
             </a:r>
             <a:r>
-              <a:rPr sz="1400" b="0" i="0">
+              <a:rPr sz="1300" b="0" i="0">
                 <a:solidFill>
                   <a:srgbClr val="DCE6EE"/>
                 </a:solidFill>
@@ -5484,14 +5484,27 @@
           <a:p>
             <a:pPr algn="l"/>
             <a:r>
-              <a:rPr sz="1400" b="0" i="0">
+              <a:rPr sz="1300" b="0" i="0">
                 <a:solidFill>
                   <a:srgbClr val="4FD69C"/>
                 </a:solidFill>
                 <a:latin typeface="Consolas"/>
                 <a:ea typeface="Microsoft JhengHei"/>
               </a:rPr>
-              <a:t>kjob: installed AI skills in ~/.claude/skills</a:t>
+              <a:t>kjob: installed AI skills in</a:t>
+            </a:r>
+          </a:p>
+          <a:p>
+            <a:pPr algn="l"/>
+            <a:r>
+              <a:rPr sz="1300" b="0" i="0">
+                <a:solidFill>
+                  <a:srgbClr val="DCE6EE"/>
+                </a:solidFill>
+                <a:latin typeface="Consolas"/>
+                <a:ea typeface="Microsoft JhengHei"/>
+              </a:rPr>
+              <a:t>      ~/.claude/skills and ~/.agents/skills</a:t>
             </a:r>
           </a:p>
         </p:txBody>

</xml_diff>

<commit_message>
Skills in ~/.agents/skills, linked from ~/.claude/skills; paste-ready examples
- The skill files are installed once, in ~/.agents/skills; Claude Code,
  which reads only ~/.claude/skills, gets a symlink per skill. An
  unedited copy made by the previous version is replaced by the link.
- TRIAL_GUIDE: copy-paste blocks create gpu_test.py + train.sh (1 GPU,
  #SBATCH settings) and ddp_train.py + train_ddp.sh (2 GPUs, torchrun);
  both run verbatim on the 10.100.1.4 cluster.
- examples/hello_gpu.py does a little real GPU work.

Co-Authored-By: Claude Opus 5.5 <noreply@anthropic.com>
</commit_message>
<xml_diff>
--- a/docs/kjob-tutorial.pptx
+++ b/docs/kjob-tutorial.pptx
@@ -5491,7 +5491,7 @@
                 <a:latin typeface="Consolas"/>
                 <a:ea typeface="Microsoft JhengHei"/>
               </a:rPr>
-              <a:t>kjob: installed AI skills in</a:t>
+              <a:t>kjob: installed AI skills in ~/.agents/skills,</a:t>
             </a:r>
           </a:p>
           <a:p>
@@ -5504,7 +5504,7 @@
                 <a:latin typeface="Consolas"/>
                 <a:ea typeface="Microsoft JhengHei"/>
               </a:rPr>
-              <a:t>      ~/.claude/skills and ~/.agents/skills</a:t>
+              <a:t>      linked from ~/.claude/skills</a:t>
             </a:r>
           </a:p>
         </p:txBody>

</xml_diff>